<commit_message>
Update: adres Bijleveldsingel 2, energielabel-schaal A+++..D, logo zonder tagline, slide 1 zonder 'voor makelaars'
</commit_message>
<xml_diff>
--- a/presentatie-makelaars.pptx
+++ b/presentatie-makelaars.pptx
@@ -3153,45 +3153,6 @@
         </p:nvSpPr>
         <p:spPr>
           <a:xfrm>
-            <a:off x="8808415" y="713232"/>
-            <a:ext cx="2743200" cy="365760"/>
-          </a:xfrm>
-          <a:prstGeom prst="rect">
-            <a:avLst/>
-          </a:prstGeom>
-          <a:noFill/>
-        </p:spPr>
-        <p:txBody>
-          <a:bodyPr wrap="square" anchor="t" lIns="0" rIns="0" tIns="0" bIns="0">
-            <a:spAutoFit/>
-          </a:bodyPr>
-          <a:lstStyle/>
-          <a:p>
-            <a:pPr algn="r">
-              <a:spcAft>
-                <a:spcPts val="0"/>
-              </a:spcAft>
-            </a:pPr>
-            <a:r>
-              <a:rPr sz="1300" b="0" i="0">
-                <a:solidFill>
-                  <a:srgbClr val="9FB0C9"/>
-                </a:solidFill>
-                <a:latin typeface="Calibri"/>
-              </a:rPr>
-              <a:t>voor makelaars</a:t>
-            </a:r>
-          </a:p>
-        </p:txBody>
-      </p:sp>
-      <p:sp>
-        <p:nvSpPr>
-          <p:cNvPr id="4" name="TextBox 3"/>
-          <p:cNvSpPr txBox="1"/>
-          <p:nvPr/>
-        </p:nvSpPr>
-        <p:spPr>
-          <a:xfrm>
             <a:off x="640080" y="2148840"/>
             <a:ext cx="7680960" cy="365760"/>
           </a:xfrm>
@@ -3225,7 +3186,7 @@
       </p:sp>
       <p:sp>
         <p:nvSpPr>
-          <p:cNvPr id="5" name="TextBox 4"/>
+          <p:cNvPr id="4" name="TextBox 3"/>
           <p:cNvSpPr txBox="1"/>
           <p:nvPr/>
         </p:nvSpPr>
@@ -3286,7 +3247,7 @@
       </p:sp>
       <p:sp>
         <p:nvSpPr>
-          <p:cNvPr id="6" name="TextBox 5"/>
+          <p:cNvPr id="5" name="TextBox 4"/>
           <p:cNvSpPr txBox="1"/>
           <p:nvPr/>
         </p:nvSpPr>
@@ -3346,7 +3307,7 @@
       </p:sp>
       <p:sp>
         <p:nvSpPr>
-          <p:cNvPr id="7" name="TextBox 6"/>
+          <p:cNvPr id="6" name="TextBox 5"/>
           <p:cNvSpPr txBox="1"/>
           <p:nvPr/>
         </p:nvSpPr>
@@ -3394,7 +3355,7 @@
       </p:sp>
       <p:sp>
         <p:nvSpPr>
-          <p:cNvPr id="8" name="Pentagon 7"/>
+          <p:cNvPr id="7" name="Pentagon 6"/>
           <p:cNvSpPr/>
           <p:nvPr/>
         </p:nvSpPr>
@@ -3407,7 +3368,7 @@
             <a:avLst/>
           </a:prstGeom>
           <a:solidFill>
-            <a:srgbClr val="00A651"/>
+            <a:srgbClr val="009A44"/>
           </a:solidFill>
           <a:ln>
             <a:noFill/>
@@ -3438,14 +3399,14 @@
       </p:sp>
       <p:sp>
         <p:nvSpPr>
-          <p:cNvPr id="9" name="TextBox 8"/>
+          <p:cNvPr id="8" name="TextBox 7"/>
           <p:cNvSpPr txBox="1"/>
           <p:nvPr/>
         </p:nvSpPr>
         <p:spPr>
           <a:xfrm>
             <a:off x="9217152" y="2039112"/>
-            <a:ext cx="457200" cy="301752"/>
+            <a:ext cx="1097280" cy="301752"/>
           </a:xfrm>
           <a:prstGeom prst="rect">
             <a:avLst/>
@@ -3472,12 +3433,21 @@
               </a:rPr>
               <a:t>A</a:t>
             </a:r>
-          </a:p>
-        </p:txBody>
-      </p:sp>
-      <p:sp>
-        <p:nvSpPr>
-          <p:cNvPr id="10" name="Pentagon 9"/>
+            <a:r>
+              <a:rPr sz="840" b="1" i="0" baseline="30000">
+                <a:solidFill>
+                  <a:srgbClr val="FFFFFF"/>
+                </a:solidFill>
+                <a:latin typeface="Calibri"/>
+              </a:rPr>
+              <a:t>+++</a:t>
+            </a:r>
+          </a:p>
+        </p:txBody>
+      </p:sp>
+      <p:sp>
+        <p:nvSpPr>
+          <p:cNvPr id="9" name="Pentagon 8"/>
           <p:cNvSpPr/>
           <p:nvPr/>
         </p:nvSpPr>
@@ -3490,7 +3460,7 @@
             <a:avLst/>
           </a:prstGeom>
           <a:solidFill>
-            <a:srgbClr val="50B848"/>
+            <a:srgbClr val="52AE32"/>
           </a:solidFill>
           <a:ln>
             <a:noFill/>
@@ -3521,14 +3491,14 @@
       </p:sp>
       <p:sp>
         <p:nvSpPr>
-          <p:cNvPr id="11" name="TextBox 10"/>
+          <p:cNvPr id="10" name="TextBox 9"/>
           <p:cNvSpPr txBox="1"/>
           <p:nvPr/>
         </p:nvSpPr>
         <p:spPr>
           <a:xfrm>
             <a:off x="9217152" y="2395728"/>
-            <a:ext cx="457200" cy="301752"/>
+            <a:ext cx="1097280" cy="301752"/>
           </a:xfrm>
           <a:prstGeom prst="rect">
             <a:avLst/>
@@ -3553,14 +3523,23 @@
                 </a:solidFill>
                 <a:latin typeface="Calibri"/>
               </a:rPr>
-              <a:t>B</a:t>
-            </a:r>
-          </a:p>
-        </p:txBody>
-      </p:sp>
-      <p:sp>
-        <p:nvSpPr>
-          <p:cNvPr id="12" name="Pentagon 11"/>
+              <a:t>A</a:t>
+            </a:r>
+            <a:r>
+              <a:rPr sz="840" b="1" i="0" baseline="30000">
+                <a:solidFill>
+                  <a:srgbClr val="FFFFFF"/>
+                </a:solidFill>
+                <a:latin typeface="Calibri"/>
+              </a:rPr>
+              <a:t>++</a:t>
+            </a:r>
+          </a:p>
+        </p:txBody>
+      </p:sp>
+      <p:sp>
+        <p:nvSpPr>
+          <p:cNvPr id="11" name="Pentagon 10"/>
           <p:cNvSpPr/>
           <p:nvPr/>
         </p:nvSpPr>
@@ -3573,7 +3552,7 @@
             <a:avLst/>
           </a:prstGeom>
           <a:solidFill>
-            <a:srgbClr val="BFD730"/>
+            <a:srgbClr val="C7D304"/>
           </a:solidFill>
           <a:ln>
             <a:noFill/>
@@ -3604,14 +3583,14 @@
       </p:sp>
       <p:sp>
         <p:nvSpPr>
-          <p:cNvPr id="13" name="TextBox 12"/>
+          <p:cNvPr id="12" name="TextBox 11"/>
           <p:cNvSpPr txBox="1"/>
           <p:nvPr/>
         </p:nvSpPr>
         <p:spPr>
           <a:xfrm>
             <a:off x="9217152" y="2752344"/>
-            <a:ext cx="457200" cy="301752"/>
+            <a:ext cx="1097280" cy="301752"/>
           </a:xfrm>
           <a:prstGeom prst="rect">
             <a:avLst/>
@@ -3632,18 +3611,27 @@
             <a:r>
               <a:rPr sz="1400" b="1" i="0">
                 <a:solidFill>
-                  <a:srgbClr val="0F172A"/>
-                </a:solidFill>
-                <a:latin typeface="Calibri"/>
-              </a:rPr>
-              <a:t>C</a:t>
-            </a:r>
-          </a:p>
-        </p:txBody>
-      </p:sp>
-      <p:sp>
-        <p:nvSpPr>
-          <p:cNvPr id="14" name="Pentagon 13"/>
+                  <a:srgbClr val="FFFFFF"/>
+                </a:solidFill>
+                <a:latin typeface="Calibri"/>
+              </a:rPr>
+              <a:t>A</a:t>
+            </a:r>
+            <a:r>
+              <a:rPr sz="840" b="1" i="0" baseline="30000">
+                <a:solidFill>
+                  <a:srgbClr val="FFFFFF"/>
+                </a:solidFill>
+                <a:latin typeface="Calibri"/>
+              </a:rPr>
+              <a:t>+</a:t>
+            </a:r>
+          </a:p>
+        </p:txBody>
+      </p:sp>
+      <p:sp>
+        <p:nvSpPr>
+          <p:cNvPr id="13" name="Pentagon 12"/>
           <p:cNvSpPr/>
           <p:nvPr/>
         </p:nvSpPr>
@@ -3656,7 +3644,7 @@
             <a:avLst/>
           </a:prstGeom>
           <a:solidFill>
-            <a:srgbClr val="FFE000"/>
+            <a:srgbClr val="FFD500"/>
           </a:solidFill>
           <a:ln>
             <a:noFill/>
@@ -3687,14 +3675,14 @@
       </p:sp>
       <p:sp>
         <p:nvSpPr>
-          <p:cNvPr id="15" name="TextBox 14"/>
+          <p:cNvPr id="14" name="TextBox 13"/>
           <p:cNvSpPr txBox="1"/>
           <p:nvPr/>
         </p:nvSpPr>
         <p:spPr>
           <a:xfrm>
             <a:off x="9217152" y="3108960"/>
-            <a:ext cx="457200" cy="301752"/>
+            <a:ext cx="1097280" cy="301752"/>
           </a:xfrm>
           <a:prstGeom prst="rect">
             <a:avLst/>
@@ -3715,18 +3703,18 @@
             <a:r>
               <a:rPr sz="1400" b="1" i="0">
                 <a:solidFill>
-                  <a:srgbClr val="0F172A"/>
-                </a:solidFill>
-                <a:latin typeface="Calibri"/>
-              </a:rPr>
-              <a:t>D</a:t>
-            </a:r>
-          </a:p>
-        </p:txBody>
-      </p:sp>
-      <p:sp>
-        <p:nvSpPr>
-          <p:cNvPr id="16" name="Pentagon 15"/>
+                  <a:srgbClr val="FFFFFF"/>
+                </a:solidFill>
+                <a:latin typeface="Calibri"/>
+              </a:rPr>
+              <a:t>A</a:t>
+            </a:r>
+          </a:p>
+        </p:txBody>
+      </p:sp>
+      <p:sp>
+        <p:nvSpPr>
+          <p:cNvPr id="15" name="Pentagon 14"/>
           <p:cNvSpPr/>
           <p:nvPr/>
         </p:nvSpPr>
@@ -3739,7 +3727,7 @@
             <a:avLst/>
           </a:prstGeom>
           <a:solidFill>
-            <a:srgbClr val="FBB400"/>
+            <a:srgbClr val="FBBA00"/>
           </a:solidFill>
           <a:ln>
             <a:noFill/>
@@ -3770,14 +3758,14 @@
       </p:sp>
       <p:sp>
         <p:nvSpPr>
-          <p:cNvPr id="17" name="TextBox 16"/>
+          <p:cNvPr id="16" name="TextBox 15"/>
           <p:cNvSpPr txBox="1"/>
           <p:nvPr/>
         </p:nvSpPr>
         <p:spPr>
           <a:xfrm>
             <a:off x="9217152" y="3465576"/>
-            <a:ext cx="457200" cy="301752"/>
+            <a:ext cx="1097280" cy="301752"/>
           </a:xfrm>
           <a:prstGeom prst="rect">
             <a:avLst/>
@@ -3798,18 +3786,18 @@
             <a:r>
               <a:rPr sz="1400" b="1" i="0">
                 <a:solidFill>
-                  <a:srgbClr val="0F172A"/>
-                </a:solidFill>
-                <a:latin typeface="Calibri"/>
-              </a:rPr>
-              <a:t>E</a:t>
-            </a:r>
-          </a:p>
-        </p:txBody>
-      </p:sp>
-      <p:sp>
-        <p:nvSpPr>
-          <p:cNvPr id="18" name="Pentagon 17"/>
+                  <a:srgbClr val="FFFFFF"/>
+                </a:solidFill>
+                <a:latin typeface="Calibri"/>
+              </a:rPr>
+              <a:t>B</a:t>
+            </a:r>
+          </a:p>
+        </p:txBody>
+      </p:sp>
+      <p:sp>
+        <p:nvSpPr>
+          <p:cNvPr id="17" name="Pentagon 16"/>
           <p:cNvSpPr/>
           <p:nvPr/>
         </p:nvSpPr>
@@ -3822,7 +3810,7 @@
             <a:avLst/>
           </a:prstGeom>
           <a:solidFill>
-            <a:srgbClr val="F37021"/>
+            <a:srgbClr val="EF7D00"/>
           </a:solidFill>
           <a:ln>
             <a:noFill/>
@@ -3853,14 +3841,14 @@
       </p:sp>
       <p:sp>
         <p:nvSpPr>
-          <p:cNvPr id="19" name="TextBox 18"/>
+          <p:cNvPr id="18" name="TextBox 17"/>
           <p:cNvSpPr txBox="1"/>
           <p:nvPr/>
         </p:nvSpPr>
         <p:spPr>
           <a:xfrm>
             <a:off x="9217152" y="3822192"/>
-            <a:ext cx="457200" cy="301752"/>
+            <a:ext cx="1097280" cy="301752"/>
           </a:xfrm>
           <a:prstGeom prst="rect">
             <a:avLst/>
@@ -3885,14 +3873,14 @@
                 </a:solidFill>
                 <a:latin typeface="Calibri"/>
               </a:rPr>
-              <a:t>F</a:t>
-            </a:r>
-          </a:p>
-        </p:txBody>
-      </p:sp>
-      <p:sp>
-        <p:nvSpPr>
-          <p:cNvPr id="20" name="Pentagon 19"/>
+              <a:t>C</a:t>
+            </a:r>
+          </a:p>
+        </p:txBody>
+      </p:sp>
+      <p:sp>
+        <p:nvSpPr>
+          <p:cNvPr id="19" name="Pentagon 18"/>
           <p:cNvSpPr/>
           <p:nvPr/>
         </p:nvSpPr>
@@ -3905,7 +3893,7 @@
             <a:avLst/>
           </a:prstGeom>
           <a:solidFill>
-            <a:srgbClr val="ED1C24"/>
+            <a:srgbClr val="E2001A"/>
           </a:solidFill>
           <a:ln>
             <a:noFill/>
@@ -3936,14 +3924,14 @@
       </p:sp>
       <p:sp>
         <p:nvSpPr>
-          <p:cNvPr id="21" name="TextBox 20"/>
+          <p:cNvPr id="20" name="TextBox 19"/>
           <p:cNvSpPr txBox="1"/>
           <p:nvPr/>
         </p:nvSpPr>
         <p:spPr>
           <a:xfrm>
             <a:off x="9217152" y="4178808"/>
-            <a:ext cx="457200" cy="301752"/>
+            <a:ext cx="1097280" cy="301752"/>
           </a:xfrm>
           <a:prstGeom prst="rect">
             <a:avLst/>
@@ -3968,14 +3956,14 @@
                 </a:solidFill>
                 <a:latin typeface="Calibri"/>
               </a:rPr>
-              <a:t>G</a:t>
+              <a:t>D</a:t>
             </a:r>
           </a:p>
         </p:txBody>
       </p:sp>
       <p:pic>
         <p:nvPicPr>
-          <p:cNvPr id="22" name="Picture 21" descr="logo-eb-white.png"/>
+          <p:cNvPr id="21" name="Picture 20" descr="logo-eb-dark.png"/>
           <p:cNvPicPr>
             <a:picLocks noChangeAspect="1"/>
           </p:cNvPicPr>
@@ -3990,7 +3978,7 @@
         <p:spPr>
           <a:xfrm>
             <a:off x="640080" y="457200"/>
-            <a:ext cx="996219" cy="932688"/>
+            <a:ext cx="1092832" cy="932688"/>
           </a:xfrm>
           <a:prstGeom prst="rect">
             <a:avLst/>
@@ -4735,7 +4723,7 @@
             <a:avLst/>
           </a:prstGeom>
           <a:solidFill>
-            <a:srgbClr val="00A651"/>
+            <a:srgbClr val="009A44"/>
           </a:solidFill>
           <a:ln>
             <a:noFill/>
@@ -4779,7 +4767,7 @@
             <a:avLst/>
           </a:prstGeom>
           <a:solidFill>
-            <a:srgbClr val="50B848"/>
+            <a:srgbClr val="52AE32"/>
           </a:solidFill>
           <a:ln>
             <a:noFill/>
@@ -4823,7 +4811,7 @@
             <a:avLst/>
           </a:prstGeom>
           <a:solidFill>
-            <a:srgbClr val="BFD730"/>
+            <a:srgbClr val="C7D304"/>
           </a:solidFill>
           <a:ln>
             <a:noFill/>
@@ -4867,7 +4855,7 @@
             <a:avLst/>
           </a:prstGeom>
           <a:solidFill>
-            <a:srgbClr val="FFE000"/>
+            <a:srgbClr val="FFD500"/>
           </a:solidFill>
           <a:ln>
             <a:noFill/>
@@ -4911,7 +4899,7 @@
             <a:avLst/>
           </a:prstGeom>
           <a:solidFill>
-            <a:srgbClr val="FBB400"/>
+            <a:srgbClr val="FBBA00"/>
           </a:solidFill>
           <a:ln>
             <a:noFill/>
@@ -4955,7 +4943,7 @@
             <a:avLst/>
           </a:prstGeom>
           <a:solidFill>
-            <a:srgbClr val="F37021"/>
+            <a:srgbClr val="EF7D00"/>
           </a:solidFill>
           <a:ln>
             <a:noFill/>
@@ -4999,7 +4987,7 @@
             <a:avLst/>
           </a:prstGeom>
           <a:solidFill>
-            <a:srgbClr val="ED1C24"/>
+            <a:srgbClr val="E2001A"/>
           </a:solidFill>
           <a:ln>
             <a:noFill/>
@@ -5030,7 +5018,7 @@
       </p:sp>
       <p:pic>
         <p:nvPicPr>
-          <p:cNvPr id="25" name="Picture 24" descr="logo-eb-white.png"/>
+          <p:cNvPr id="25" name="Picture 24" descr="logo-eb-dark.png"/>
           <p:cNvPicPr>
             <a:picLocks noChangeAspect="1"/>
           </p:cNvPicPr>
@@ -5044,8 +5032,8 @@
         </p:blipFill>
         <p:spPr>
           <a:xfrm>
-            <a:off x="10867935" y="384048"/>
-            <a:ext cx="683680" cy="640080"/>
+            <a:off x="10801633" y="384048"/>
+            <a:ext cx="749982" cy="640080"/>
           </a:xfrm>
           <a:prstGeom prst="rect">
             <a:avLst/>
@@ -6654,8 +6642,8 @@
         </p:blipFill>
         <p:spPr>
           <a:xfrm>
-            <a:off x="10867935" y="384048"/>
-            <a:ext cx="683680" cy="640080"/>
+            <a:off x="10801633" y="384048"/>
+            <a:ext cx="749982" cy="640080"/>
           </a:xfrm>
           <a:prstGeom prst="rect">
             <a:avLst/>
@@ -7311,8 +7299,8 @@
         </p:blipFill>
         <p:spPr>
           <a:xfrm>
-            <a:off x="10867935" y="384048"/>
-            <a:ext cx="683680" cy="640080"/>
+            <a:off x="10801633" y="384048"/>
+            <a:ext cx="749982" cy="640080"/>
           </a:xfrm>
           <a:prstGeom prst="rect">
             <a:avLst/>
@@ -8331,8 +8319,8 @@
         </p:blipFill>
         <p:spPr>
           <a:xfrm>
-            <a:off x="10867935" y="384048"/>
-            <a:ext cx="683680" cy="640080"/>
+            <a:off x="10801633" y="384048"/>
+            <a:ext cx="749982" cy="640080"/>
           </a:xfrm>
           <a:prstGeom prst="rect">
             <a:avLst/>
@@ -8705,7 +8693,7 @@
                 </a:solidFill>
                 <a:latin typeface="Calibri"/>
               </a:rPr>
-              <a:t>    ·    Bijleveld, Zendel 2, Nijmegen</a:t>
+              <a:t>    ·    Bijleveldsingel 2, Nijmegen</a:t>
             </a:r>
           </a:p>
         </p:txBody>
@@ -8883,7 +8871,7 @@
       </p:sp>
       <p:pic>
         <p:nvPicPr>
-          <p:cNvPr id="14" name="Picture 13" descr="logo-eb-white.png"/>
+          <p:cNvPr id="14" name="Picture 13" descr="logo-eb-dark.png"/>
           <p:cNvPicPr>
             <a:picLocks noChangeAspect="1"/>
           </p:cNvPicPr>
@@ -8898,7 +8886,7 @@
         <p:spPr>
           <a:xfrm>
             <a:off x="640080" y="457200"/>
-            <a:ext cx="996219" cy="932688"/>
+            <a:ext cx="1092832" cy="932688"/>
           </a:xfrm>
           <a:prstGeom prst="rect">
             <a:avLst/>
@@ -10408,8 +10396,8 @@
         </p:blipFill>
         <p:spPr>
           <a:xfrm>
-            <a:off x="10867935" y="384048"/>
-            <a:ext cx="683680" cy="640080"/>
+            <a:off x="10801633" y="384048"/>
+            <a:ext cx="749982" cy="640080"/>
           </a:xfrm>
           <a:prstGeom prst="rect">
             <a:avLst/>
@@ -10611,7 +10599,7 @@
                 </a:solidFill>
                 <a:latin typeface="Calibri"/>
               </a:rPr>
-              <a:t>Het energielabel laat zien hoe energiezuinig een gebouw is — op een schaal van A+++++ (zeer zuinig) tot G.</a:t>
+              <a:t>Het energielabel laat zien hoe energiezuinig een gebouw is — van zeer zuinig (groen) tot onzuinig (rood).</a:t>
             </a:r>
           </a:p>
           <a:p>
@@ -10942,7 +10930,7 @@
             <a:avLst/>
           </a:prstGeom>
           <a:solidFill>
-            <a:srgbClr val="00A651"/>
+            <a:srgbClr val="009A44"/>
           </a:solidFill>
           <a:ln>
             <a:noFill/>
@@ -10980,7 +10968,7 @@
         <p:spPr>
           <a:xfrm>
             <a:off x="8394192" y="2414016"/>
-            <a:ext cx="457200" cy="329184"/>
+            <a:ext cx="1097280" cy="329184"/>
           </a:xfrm>
           <a:prstGeom prst="rect">
             <a:avLst/>
@@ -11006,6 +10994,15 @@
                 <a:latin typeface="Calibri"/>
               </a:rPr>
               <a:t>A</a:t>
+            </a:r>
+            <a:r>
+              <a:rPr sz="900" b="1" i="0" baseline="30000">
+                <a:solidFill>
+                  <a:srgbClr val="FFFFFF"/>
+                </a:solidFill>
+                <a:latin typeface="Calibri"/>
+              </a:rPr>
+              <a:t>+++</a:t>
             </a:r>
           </a:p>
         </p:txBody>
@@ -11025,7 +11022,7 @@
             <a:avLst/>
           </a:prstGeom>
           <a:solidFill>
-            <a:srgbClr val="50B848"/>
+            <a:srgbClr val="52AE32"/>
           </a:solidFill>
           <a:ln>
             <a:noFill/>
@@ -11063,7 +11060,7 @@
         <p:spPr>
           <a:xfrm>
             <a:off x="8394192" y="2807208"/>
-            <a:ext cx="457200" cy="329184"/>
+            <a:ext cx="1097280" cy="329184"/>
           </a:xfrm>
           <a:prstGeom prst="rect">
             <a:avLst/>
@@ -11088,7 +11085,16 @@
                 </a:solidFill>
                 <a:latin typeface="Calibri"/>
               </a:rPr>
-              <a:t>B</a:t>
+              <a:t>A</a:t>
+            </a:r>
+            <a:r>
+              <a:rPr sz="900" b="1" i="0" baseline="30000">
+                <a:solidFill>
+                  <a:srgbClr val="FFFFFF"/>
+                </a:solidFill>
+                <a:latin typeface="Calibri"/>
+              </a:rPr>
+              <a:t>++</a:t>
             </a:r>
           </a:p>
         </p:txBody>
@@ -11108,7 +11114,7 @@
             <a:avLst/>
           </a:prstGeom>
           <a:solidFill>
-            <a:srgbClr val="BFD730"/>
+            <a:srgbClr val="C7D304"/>
           </a:solidFill>
           <a:ln>
             <a:noFill/>
@@ -11146,7 +11152,7 @@
         <p:spPr>
           <a:xfrm>
             <a:off x="8394192" y="3200400"/>
-            <a:ext cx="457200" cy="329184"/>
+            <a:ext cx="1097280" cy="329184"/>
           </a:xfrm>
           <a:prstGeom prst="rect">
             <a:avLst/>
@@ -11167,11 +11173,20 @@
             <a:r>
               <a:rPr sz="1500" b="1" i="0">
                 <a:solidFill>
-                  <a:srgbClr val="0F172A"/>
-                </a:solidFill>
-                <a:latin typeface="Calibri"/>
-              </a:rPr>
-              <a:t>C</a:t>
+                  <a:srgbClr val="FFFFFF"/>
+                </a:solidFill>
+                <a:latin typeface="Calibri"/>
+              </a:rPr>
+              <a:t>A</a:t>
+            </a:r>
+            <a:r>
+              <a:rPr sz="900" b="1" i="0" baseline="30000">
+                <a:solidFill>
+                  <a:srgbClr val="FFFFFF"/>
+                </a:solidFill>
+                <a:latin typeface="Calibri"/>
+              </a:rPr>
+              <a:t>+</a:t>
             </a:r>
           </a:p>
         </p:txBody>
@@ -11191,7 +11206,7 @@
             <a:avLst/>
           </a:prstGeom>
           <a:solidFill>
-            <a:srgbClr val="FFE000"/>
+            <a:srgbClr val="FFD500"/>
           </a:solidFill>
           <a:ln>
             <a:noFill/>
@@ -11229,7 +11244,7 @@
         <p:spPr>
           <a:xfrm>
             <a:off x="8394192" y="3593592"/>
-            <a:ext cx="457200" cy="329184"/>
+            <a:ext cx="1097280" cy="329184"/>
           </a:xfrm>
           <a:prstGeom prst="rect">
             <a:avLst/>
@@ -11250,11 +11265,11 @@
             <a:r>
               <a:rPr sz="1500" b="1" i="0">
                 <a:solidFill>
-                  <a:srgbClr val="0F172A"/>
-                </a:solidFill>
-                <a:latin typeface="Calibri"/>
-              </a:rPr>
-              <a:t>D</a:t>
+                  <a:srgbClr val="FFFFFF"/>
+                </a:solidFill>
+                <a:latin typeface="Calibri"/>
+              </a:rPr>
+              <a:t>A</a:t>
             </a:r>
           </a:p>
         </p:txBody>
@@ -11274,7 +11289,7 @@
             <a:avLst/>
           </a:prstGeom>
           <a:solidFill>
-            <a:srgbClr val="FBB400"/>
+            <a:srgbClr val="FBBA00"/>
           </a:solidFill>
           <a:ln>
             <a:noFill/>
@@ -11312,7 +11327,7 @@
         <p:spPr>
           <a:xfrm>
             <a:off x="8394192" y="3986784"/>
-            <a:ext cx="457200" cy="329184"/>
+            <a:ext cx="1097280" cy="329184"/>
           </a:xfrm>
           <a:prstGeom prst="rect">
             <a:avLst/>
@@ -11333,11 +11348,11 @@
             <a:r>
               <a:rPr sz="1500" b="1" i="0">
                 <a:solidFill>
-                  <a:srgbClr val="0F172A"/>
-                </a:solidFill>
-                <a:latin typeface="Calibri"/>
-              </a:rPr>
-              <a:t>E</a:t>
+                  <a:srgbClr val="FFFFFF"/>
+                </a:solidFill>
+                <a:latin typeface="Calibri"/>
+              </a:rPr>
+              <a:t>B</a:t>
             </a:r>
           </a:p>
         </p:txBody>
@@ -11357,7 +11372,7 @@
             <a:avLst/>
           </a:prstGeom>
           <a:solidFill>
-            <a:srgbClr val="F37021"/>
+            <a:srgbClr val="EF7D00"/>
           </a:solidFill>
           <a:ln>
             <a:noFill/>
@@ -11395,7 +11410,7 @@
         <p:spPr>
           <a:xfrm>
             <a:off x="8394192" y="4379976"/>
-            <a:ext cx="457200" cy="329184"/>
+            <a:ext cx="1097280" cy="329184"/>
           </a:xfrm>
           <a:prstGeom prst="rect">
             <a:avLst/>
@@ -11420,7 +11435,7 @@
                 </a:solidFill>
                 <a:latin typeface="Calibri"/>
               </a:rPr>
-              <a:t>F</a:t>
+              <a:t>C</a:t>
             </a:r>
           </a:p>
         </p:txBody>
@@ -11440,7 +11455,7 @@
             <a:avLst/>
           </a:prstGeom>
           <a:solidFill>
-            <a:srgbClr val="ED1C24"/>
+            <a:srgbClr val="E2001A"/>
           </a:solidFill>
           <a:ln>
             <a:noFill/>
@@ -11478,7 +11493,7 @@
         <p:spPr>
           <a:xfrm>
             <a:off x="8394192" y="4773168"/>
-            <a:ext cx="457200" cy="329184"/>
+            <a:ext cx="1097280" cy="329184"/>
           </a:xfrm>
           <a:prstGeom prst="rect">
             <a:avLst/>
@@ -11503,7 +11518,7 @@
                 </a:solidFill>
                 <a:latin typeface="Calibri"/>
               </a:rPr>
-              <a:t>G</a:t>
+              <a:t>D</a:t>
             </a:r>
           </a:p>
         </p:txBody>
@@ -11563,8 +11578,8 @@
         </p:blipFill>
         <p:spPr>
           <a:xfrm>
-            <a:off x="10867935" y="384048"/>
-            <a:ext cx="683680" cy="640080"/>
+            <a:off x="10801633" y="384048"/>
+            <a:ext cx="749982" cy="640080"/>
           </a:xfrm>
           <a:prstGeom prst="rect">
             <a:avLst/>
@@ -12556,8 +12571,8 @@
         </p:blipFill>
         <p:spPr>
           <a:xfrm>
-            <a:off x="10867935" y="384048"/>
-            <a:ext cx="683680" cy="640080"/>
+            <a:off x="10801633" y="384048"/>
+            <a:ext cx="749982" cy="640080"/>
           </a:xfrm>
           <a:prstGeom prst="rect">
             <a:avLst/>
@@ -13437,8 +13452,8 @@
         </p:blipFill>
         <p:spPr>
           <a:xfrm>
-            <a:off x="10867935" y="384048"/>
-            <a:ext cx="683680" cy="640080"/>
+            <a:off x="10801633" y="384048"/>
+            <a:ext cx="749982" cy="640080"/>
           </a:xfrm>
           <a:prstGeom prst="rect">
             <a:avLst/>
@@ -14035,7 +14050,7 @@
             <a:avLst/>
           </a:prstGeom>
           <a:solidFill>
-            <a:srgbClr val="BFD730"/>
+            <a:srgbClr val="EF7D00"/>
           </a:solidFill>
           <a:ln>
             <a:noFill/>
@@ -14094,7 +14109,7 @@
             <a:r>
               <a:rPr sz="2400" b="1" i="0">
                 <a:solidFill>
-                  <a:srgbClr val="0F172A"/>
+                  <a:srgbClr val="FFFFFF"/>
                 </a:solidFill>
                 <a:latin typeface="Calibri"/>
               </a:rPr>
@@ -14162,7 +14177,7 @@
             <a:avLst/>
           </a:prstGeom>
           <a:solidFill>
-            <a:srgbClr val="00A651"/>
+            <a:srgbClr val="FFD500"/>
           </a:solidFill>
           <a:ln>
             <a:noFill/>
@@ -14669,8 +14684,8 @@
         </p:blipFill>
         <p:spPr>
           <a:xfrm>
-            <a:off x="10867935" y="384048"/>
-            <a:ext cx="683680" cy="640080"/>
+            <a:off x="10801633" y="384048"/>
+            <a:ext cx="749982" cy="640080"/>
           </a:xfrm>
           <a:prstGeom prst="rect">
             <a:avLst/>
@@ -15549,8 +15564,8 @@
         </p:blipFill>
         <p:spPr>
           <a:xfrm>
-            <a:off x="10867935" y="384048"/>
-            <a:ext cx="683680" cy="640080"/>
+            <a:off x="10801633" y="384048"/>
+            <a:ext cx="749982" cy="640080"/>
           </a:xfrm>
           <a:prstGeom prst="rect">
             <a:avLst/>
@@ -17060,8 +17075,8 @@
         </p:blipFill>
         <p:spPr>
           <a:xfrm>
-            <a:off x="10867935" y="384048"/>
-            <a:ext cx="683680" cy="640080"/>
+            <a:off x="10801633" y="384048"/>
+            <a:ext cx="749982" cy="640080"/>
           </a:xfrm>
           <a:prstGeom prst="rect">
             <a:avLst/>
@@ -17998,8 +18013,8 @@
         </p:blipFill>
         <p:spPr>
           <a:xfrm>
-            <a:off x="10867935" y="384048"/>
-            <a:ext cx="683680" cy="640080"/>
+            <a:off x="10801633" y="384048"/>
+            <a:ext cx="749982" cy="640080"/>
           </a:xfrm>
           <a:prstGeom prst="rect">
             <a:avLst/>

</xml_diff>